<commit_message>
MultiPart: exact aantal autobedrijven uit Apollo
Klant gaf akkoord om de betaalde zoekopdracht te draaien, dus de
schatting is vervangen door het echte getal. Apollo geeft 1.751
Nederlandse autobedrijven onder NAICS 4411 (1 credit).

- 1.500+ wordt 1.751, de kop wordt "Precies 1.751 autobedrijven"
- beldagen voor de hele markt van 19 naar 22
- doorlooptijdtabel opnieuw gerekend: 4 beldagen in 6 werkperiodes
  (24 weken), 6 in 4 (16 weken), 8 in 3 (12 weken)
- afsluiter benoemt nu expliciet dat het aantal bedrijven geteld is en
  alleen het aantal pogingen per bedrijf een indicatie

Co-Authored-By: Claude Opus 5 <noreply@anthropic.com>
Claude-Session: https://claude.ai/code/session_0141FN3f3hHkYQHTyvTJJGrw
</commit_message>
<xml_diff>
--- a/output/LINK. voorstel MultiPart.pptx
+++ b/output/LINK. voorstel MultiPart.pptx
@@ -9847,7 +9847,7 @@
                 <a:ea typeface="Arial" pitchFamily="34" charset="-122"/>
                 <a:cs typeface="Arial" pitchFamily="34" charset="-120"/>
               </a:rPr>
-              <a:t>Ruim </a:t>
+              <a:t>Precies </a:t>
             </a:r>
             <a:pPr algn="l" indent="0" marL="0">
               <a:lnSpc>
@@ -9864,7 +9864,7 @@
                 <a:ea typeface="Georgia" pitchFamily="34" charset="-122"/>
                 <a:cs typeface="Georgia" pitchFamily="34" charset="-120"/>
               </a:rPr>
-              <a:t>1.500 autobedrijven</a:t>
+              <a:t>1.751 autobedrijven</a:t>
             </a:r>
             <a:pPr algn="l" indent="0" marL="0">
               <a:lnSpc>
@@ -9942,7 +9942,7 @@
                 <a:ea typeface="Arial" pitchFamily="34" charset="-122"/>
                 <a:cs typeface="Arial" pitchFamily="34" charset="-120"/>
               </a:rPr>
-              <a:t>1.500+</a:t>
+              <a:t>1.751</a:t>
             </a:r>
             <a:endParaRPr lang="en-US" sz="3600" dirty="0"/>
           </a:p>
@@ -10226,7 +10226,7 @@
                 <a:ea typeface="Arial" pitchFamily="34" charset="-122"/>
                 <a:cs typeface="Arial" pitchFamily="34" charset="-120"/>
               </a:rPr>
-              <a:t>± 19</a:t>
+              <a:t>± 22</a:t>
             </a:r>
             <a:endParaRPr lang="en-US" sz="3600" dirty="0"/>
           </a:p>
@@ -10508,7 +10508,7 @@
                 <a:ea typeface="Arial" pitchFamily="34" charset="-122"/>
                 <a:cs typeface="Arial" pitchFamily="34" charset="-120"/>
               </a:rPr>
-              <a:t>De aantallen zijn een indicatie. Het aantal pogingen per bedrijf komt uit onze eigen campagnes, de marktomvang uit onze datatool. In de kick-off scherpen we de lijst aan op merk, omvang en regio.</a:t>
+              <a:t>Het aantal bedrijven is geteld, niet geschat. Het aantal pogingen per bedrijf komt uit onze eigen campagnes en is dus een indicatie. In de kick-off scherpen we de lijst aan op merk, omvang en regio.</a:t>
             </a:r>
             <a:endParaRPr lang="en-US" sz="1200" dirty="0"/>
           </a:p>
@@ -11028,7 +11028,7 @@
                 <a:ea typeface="Arial" pitchFamily="34" charset="-122"/>
                 <a:cs typeface="Arial" pitchFamily="34" charset="-120"/>
               </a:rPr>
-              <a:t>5 werkperiodes</a:t>
+              <a:t>6 werkperiodes</a:t>
             </a:r>
             <a:endParaRPr lang="en-US" sz="1250" dirty="0"/>
           </a:p>
@@ -11067,7 +11067,7 @@
                 <a:ea typeface="Arial" pitchFamily="34" charset="-122"/>
                 <a:cs typeface="Arial" pitchFamily="34" charset="-120"/>
               </a:rPr>
-              <a:t>20 weken</a:t>
+              <a:t>24 weken</a:t>
             </a:r>
             <a:endParaRPr lang="en-US" sz="1250" dirty="0"/>
           </a:p>
@@ -11207,7 +11207,7 @@
                 <a:ea typeface="Arial" pitchFamily="34" charset="-122"/>
                 <a:cs typeface="Arial" pitchFamily="34" charset="-120"/>
               </a:rPr>
-              <a:t>13 weken</a:t>
+              <a:t>16 weken</a:t>
             </a:r>
             <a:endParaRPr lang="en-US" sz="1250" dirty="0"/>
           </a:p>
@@ -11369,7 +11369,7 @@
                 <a:ea typeface="Arial" pitchFamily="34" charset="-122"/>
                 <a:cs typeface="Arial" pitchFamily="34" charset="-120"/>
               </a:rPr>
-              <a:t>10 weken</a:t>
+              <a:t>12 weken</a:t>
             </a:r>
             <a:endParaRPr lang="en-US" sz="1250" dirty="0"/>
           </a:p>
@@ -11428,7 +11428,7 @@
                 <a:ea typeface="Arial" pitchFamily="34" charset="-122"/>
                 <a:cs typeface="Arial" pitchFamily="34" charset="-120"/>
               </a:rPr>
-              <a:t>Na één ronde begin je opnieuw bij de bedrijven die toen net getekend hadden of geen tijd hadden. Elke ronde levert nieuwe kansen op, want contracten lopen af en voorraden wisselen.</a:t>
+              <a:t>Met 22 beldagen heb je elk autobedrijf in Nederland één keer gesproken. Daarna begin je opnieuw bij de bedrijven die toen net getekend hadden of geen tijd hadden. Contracten lopen af en voorraden wisselen, dus elke ronde levert nieuwe kansen op.</a:t>
             </a:r>
             <a:endParaRPr lang="en-US" sz="1200" dirty="0"/>
           </a:p>

</xml_diff>